<commit_message>
docs: add Development Team & Roles slide to Proposal Review presentation
</commit_message>
<xml_diff>
--- a/Cadence_Proposal_Review.pptx
+++ b/Cadence_Proposal_Review.pptx
@@ -20,6 +20,7 @@
     <p:sldId id="265" r:id="rId11"/>
     <p:sldId id="266" r:id="rId12"/>
     <p:sldId id="267" r:id="rId13"/>
+    <p:sldId id="269" r:id="rId20"/>
     <p:sldId id="268" r:id="rId14"/>
   </p:sldIdLst>
   <p:sldSz cx="12192000" cy="6858000"/>
@@ -7538,7 +7539,7 @@
       <p:sp>
         <p:nvSpPr>
           <p:cNvPr id="22" name="Text 16">
-            <a:hlinkClick r:id="rId8" action="ppaction://hlinksldjump"/>
+            <a:hlinkClick action="ppaction://hlinksldjump" r:id="rId9"/>
           </p:cNvPr>
           <p:cNvSpPr/>
           <p:nvPr/>
@@ -7577,7 +7578,7 @@
                   </a:extLst>
                 </a:hlinkClick>
               </a:rPr>
-              <a:t>CONTINUE TO SANCTION DECISION  →</a:t>
+              <a:t>CONTINUE TO TEAM ROLES  →</a:t>
             </a:r>
             <a:endParaRPr lang="en-US" sz="1100" dirty="0"/>
           </a:p>
@@ -7939,6 +7940,1466 @@
               <a:t>RETURN TO REVIEW BOARD</a:t>
             </a:r>
             <a:endParaRPr lang="en-US" sz="1100" dirty="0"/>
+          </a:p>
+        </p:txBody>
+      </p:sp>
+    </p:spTree>
+  </p:cSld>
+  <p:clrMapOvr>
+    <a:masterClrMapping/>
+  </p:clrMapOvr>
+</p:sld>
+</file>
+
+<file path=ppt/slides/slide14.xml><?xml version="1.0" encoding="utf-8"?>
+<p:sld xmlns:a="http://schemas.openxmlformats.org/drawingml/2006/main" xmlns:p="http://schemas.openxmlformats.org/presentationml/2006/main" xmlns:r="http://schemas.openxmlformats.org/officeDocument/2006/relationships">
+  <p:cSld>
+    <p:bg>
+      <p:bgPr>
+        <a:solidFill>
+          <a:srgbClr val="FFFFFF"/>
+        </a:solidFill>
+        <a:effectLst/>
+      </p:bgPr>
+    </p:bg>
+    <p:spTree>
+      <p:nvGrpSpPr>
+        <p:cNvPr id="1" name=""/>
+        <p:cNvGrpSpPr/>
+        <p:nvPr/>
+      </p:nvGrpSpPr>
+      <p:grpSpPr/>
+      <p:sp>
+        <p:nvSpPr>
+          <p:cNvPr id="2" name="TextBox 1"/>
+          <p:cNvSpPr txBox="1"/>
+          <p:nvPr/>
+        </p:nvSpPr>
+        <p:spPr>
+          <a:xfrm>
+            <a:off x="548640" y="384048"/>
+            <a:ext cx="8229600" cy="274320"/>
+          </a:xfrm>
+          <a:prstGeom prst="rect">
+            <a:avLst/>
+          </a:prstGeom>
+          <a:noFill/>
+        </p:spPr>
+        <p:txBody>
+          <a:bodyPr wrap="square" lIns="0" rIns="0" tIns="0" bIns="0">
+            <a:spAutoFit/>
+          </a:bodyPr>
+          <a:lstStyle/>
+          <a:p>
+            <a:pPr>
+              <a:defRPr sz="1200" b="1">
+                <a:solidFill>
+                  <a:srgbClr val="E05C2A"/>
+                </a:solidFill>
+                <a:latin typeface="Calibri"/>
+              </a:defRPr>
+            </a:pPr>
+            <a:r>
+              <a:t>SECTION 10 · DEVELOPMENT TEAM &amp; ROLES</a:t>
+            </a:r>
+          </a:p>
+        </p:txBody>
+      </p:sp>
+      <p:sp>
+        <p:nvSpPr>
+          <p:cNvPr id="3" name="TextBox 2"/>
+          <p:cNvSpPr txBox="1"/>
+          <p:nvPr/>
+        </p:nvSpPr>
+        <p:spPr>
+          <a:xfrm>
+            <a:off x="548640" y="640080"/>
+            <a:ext cx="9601200" cy="640080"/>
+          </a:xfrm>
+          <a:prstGeom prst="rect">
+            <a:avLst/>
+          </a:prstGeom>
+          <a:noFill/>
+        </p:spPr>
+        <p:txBody>
+          <a:bodyPr wrap="square" lIns="0" rIns="0" tIns="0" bIns="0">
+            <a:spAutoFit/>
+          </a:bodyPr>
+          <a:lstStyle/>
+          <a:p>
+            <a:pPr>
+              <a:defRPr sz="2800" b="1">
+                <a:solidFill>
+                  <a:srgbClr val="14213D"/>
+                </a:solidFill>
+                <a:latin typeface="Cambria"/>
+              </a:defRPr>
+            </a:pPr>
+            <a:r>
+              <a:t>Development Team &amp; Roles</a:t>
+            </a:r>
+          </a:p>
+        </p:txBody>
+      </p:sp>
+      <p:sp>
+        <p:nvSpPr>
+          <p:cNvPr id="4" name="TextBox 3"/>
+          <p:cNvSpPr txBox="1"/>
+          <p:nvPr/>
+        </p:nvSpPr>
+        <p:spPr>
+          <a:xfrm>
+            <a:off x="548640" y="1371600"/>
+            <a:ext cx="10607040" cy="320040"/>
+          </a:xfrm>
+          <a:prstGeom prst="rect">
+            <a:avLst/>
+          </a:prstGeom>
+          <a:noFill/>
+        </p:spPr>
+        <p:txBody>
+          <a:bodyPr wrap="square" lIns="0" rIns="0" tIns="0" bIns="0">
+            <a:spAutoFit/>
+          </a:bodyPr>
+          <a:lstStyle/>
+          <a:p>
+            <a:pPr>
+              <a:defRPr sz="1250">
+                <a:solidFill>
+                  <a:srgbClr val="2C355C"/>
+                </a:solidFill>
+                <a:latin typeface="Calibri"/>
+              </a:defRPr>
+            </a:pPr>
+            <a:r>
+              <a:t>Balanced, cross-functional role allocation to ensure efficient collaboration without development silos.</a:t>
+            </a:r>
+          </a:p>
+        </p:txBody>
+      </p:sp>
+      <p:sp>
+        <p:nvSpPr>
+          <p:cNvPr id="5" name="Rectangle 4"/>
+          <p:cNvSpPr/>
+          <p:nvPr/>
+        </p:nvSpPr>
+        <p:spPr>
+          <a:xfrm>
+            <a:off x="548640" y="1828800"/>
+            <a:ext cx="2650236" cy="4150000"/>
+          </a:xfrm>
+          <a:prstGeom prst="rect">
+            <a:avLst/>
+          </a:prstGeom>
+          <a:solidFill>
+            <a:srgbClr val="EDF2FB"/>
+          </a:solidFill>
+          <a:ln>
+            <a:noFill/>
+          </a:ln>
+        </p:spPr>
+        <p:style>
+          <a:lnRef idx="1">
+            <a:schemeClr val="accent1"/>
+          </a:lnRef>
+          <a:fillRef idx="3">
+            <a:schemeClr val="accent1"/>
+          </a:fillRef>
+          <a:effectRef idx="2">
+            <a:schemeClr val="accent1"/>
+          </a:effectRef>
+          <a:fontRef idx="minor">
+            <a:schemeClr val="lt1"/>
+          </a:fontRef>
+        </p:style>
+        <p:txBody>
+          <a:bodyPr rtlCol="0" anchor="ctr"/>
+          <a:lstStyle/>
+          <a:p>
+            <a:pPr algn="ctr"/>
+          </a:p>
+        </p:txBody>
+      </p:sp>
+      <p:sp>
+        <p:nvSpPr>
+          <p:cNvPr id="6" name="Oval 5"/>
+          <p:cNvSpPr/>
+          <p:nvPr/>
+        </p:nvSpPr>
+        <p:spPr>
+          <a:xfrm>
+            <a:off x="713232" y="1993392"/>
+            <a:ext cx="502920" cy="502920"/>
+          </a:xfrm>
+          <a:prstGeom prst="ellipse">
+            <a:avLst/>
+          </a:prstGeom>
+          <a:solidFill>
+            <a:srgbClr val="DCE5F7"/>
+          </a:solidFill>
+          <a:ln>
+            <a:noFill/>
+          </a:ln>
+        </p:spPr>
+        <p:style>
+          <a:lnRef idx="1">
+            <a:schemeClr val="accent1"/>
+          </a:lnRef>
+          <a:fillRef idx="3">
+            <a:schemeClr val="accent1"/>
+          </a:fillRef>
+          <a:effectRef idx="2">
+            <a:schemeClr val="accent1"/>
+          </a:effectRef>
+          <a:fontRef idx="minor">
+            <a:schemeClr val="lt1"/>
+          </a:fontRef>
+        </p:style>
+        <p:txBody>
+          <a:bodyPr rtlCol="0" anchor="ctr"/>
+          <a:lstStyle/>
+          <a:p>
+            <a:pPr algn="ctr"/>
+          </a:p>
+        </p:txBody>
+      </p:sp>
+      <p:pic>
+        <p:nvPicPr>
+          <p:cNvPr id="7" name="Picture 6" descr="image.png"/>
+          <p:cNvPicPr>
+            <a:picLocks noChangeAspect="1"/>
+          </p:cNvPicPr>
+          <p:nvPr/>
+        </p:nvPicPr>
+        <p:blipFill>
+          <a:blip r:embed="rId2"/>
+          <a:stretch>
+            <a:fillRect/>
+          </a:stretch>
+        </p:blipFill>
+        <p:spPr>
+          <a:xfrm>
+            <a:off x="843991" y="2124151"/>
+            <a:ext cx="241402" cy="241402"/>
+          </a:xfrm>
+          <a:prstGeom prst="rect">
+            <a:avLst/>
+          </a:prstGeom>
+        </p:spPr>
+      </p:pic>
+      <p:sp>
+        <p:nvSpPr>
+          <p:cNvPr id="8" name="TextBox 7"/>
+          <p:cNvSpPr txBox="1"/>
+          <p:nvPr/>
+        </p:nvSpPr>
+        <p:spPr>
+          <a:xfrm>
+            <a:off x="1298640" y="1948800"/>
+            <a:ext cx="1750000" cy="600000"/>
+          </a:xfrm>
+          <a:prstGeom prst="rect">
+            <a:avLst/>
+          </a:prstGeom>
+          <a:noFill/>
+        </p:spPr>
+        <p:txBody>
+          <a:bodyPr wrap="square" lIns="0" rIns="0" tIns="0" bIns="0">
+            <a:spAutoFit/>
+          </a:bodyPr>
+          <a:lstStyle/>
+          <a:p>
+            <a:pPr>
+              <a:spcAft>
+                <a:spcPts val="100"/>
+              </a:spcAft>
+              <a:defRPr sz="1300" b="1">
+                <a:solidFill>
+                  <a:srgbClr val="14213D"/>
+                </a:solidFill>
+                <a:latin typeface="Calibri"/>
+              </a:defRPr>
+            </a:pPr>
+            <a:r>
+              <a:t>Godfrey</a:t>
+            </a:r>
+          </a:p>
+          <a:p>
+            <a:pPr>
+              <a:defRPr sz="950" b="1">
+                <a:solidFill>
+                  <a:srgbClr val="E05C2A"/>
+                </a:solidFill>
+                <a:latin typeface="Calibri"/>
+              </a:defRPr>
+            </a:pPr>
+            <a:r>
+              <a:t>Lead Full-Stack Architect</a:t>
+            </a:r>
+          </a:p>
+        </p:txBody>
+      </p:sp>
+      <p:sp>
+        <p:nvSpPr>
+          <p:cNvPr id="9" name="TextBox 8"/>
+          <p:cNvSpPr txBox="1"/>
+          <p:nvPr/>
+        </p:nvSpPr>
+        <p:spPr>
+          <a:xfrm>
+            <a:off x="713232" y="2628800"/>
+            <a:ext cx="2321052" cy="3250000"/>
+          </a:xfrm>
+          <a:prstGeom prst="rect">
+            <a:avLst/>
+          </a:prstGeom>
+          <a:noFill/>
+        </p:spPr>
+        <p:txBody>
+          <a:bodyPr wrap="square" lIns="0" rIns="0" tIns="0" bIns="0">
+            <a:spAutoFit/>
+          </a:bodyPr>
+          <a:lstStyle/>
+          <a:p>
+            <a:pPr>
+              <a:spcAft>
+                <a:spcPts val="200"/>
+              </a:spcAft>
+              <a:defRPr sz="950" b="1">
+                <a:solidFill>
+                  <a:srgbClr val="14213D"/>
+                </a:solidFill>
+                <a:latin typeface="Calibri"/>
+              </a:defRPr>
+            </a:pPr>
+            <a:r>
+              <a:t>FOCUS</a:t>
+            </a:r>
+          </a:p>
+          <a:p>
+            <a:pPr>
+              <a:spcAft>
+                <a:spcPts val="800"/>
+              </a:spcAft>
+              <a:defRPr sz="950">
+                <a:solidFill>
+                  <a:srgbClr val="5C6B8A"/>
+                </a:solidFill>
+                <a:latin typeface="Calibri"/>
+              </a:defRPr>
+            </a:pPr>
+            <a:r>
+              <a:t>Full-Stack Design, tRPC APIs, AI Orchestration</a:t>
+            </a:r>
+          </a:p>
+          <a:p>
+            <a:pPr>
+              <a:spcAft>
+                <a:spcPts val="400"/>
+              </a:spcAft>
+              <a:defRPr sz="950" b="1">
+                <a:solidFill>
+                  <a:srgbClr val="14213D"/>
+                </a:solidFill>
+                <a:latin typeface="Calibri"/>
+              </a:defRPr>
+            </a:pPr>
+            <a:r>
+              <a:t>RESPONSIBILITIES</a:t>
+            </a:r>
+          </a:p>
+          <a:p>
+            <a:pPr>
+              <a:spcAft>
+                <a:spcPts val="300"/>
+              </a:spcAft>
+              <a:defRPr sz="900">
+                <a:solidFill>
+                  <a:srgbClr val="5C6B8A"/>
+                </a:solidFill>
+                <a:latin typeface="Calibri"/>
+              </a:defRPr>
+            </a:pPr>
+            <a:r>
+              <a:t>•  Next.js 16 core architecture</a:t>
+            </a:r>
+          </a:p>
+          <a:p>
+            <a:pPr>
+              <a:spcAft>
+                <a:spcPts val="300"/>
+              </a:spcAft>
+              <a:defRPr sz="900">
+                <a:solidFill>
+                  <a:srgbClr val="5C6B8A"/>
+                </a:solidFill>
+                <a:latin typeface="Calibri"/>
+              </a:defRPr>
+            </a:pPr>
+            <a:r>
+              <a:t>•  End-to-end type safety (tRPC/Zod)</a:t>
+            </a:r>
+          </a:p>
+          <a:p>
+            <a:pPr>
+              <a:spcAft>
+                <a:spcPts val="300"/>
+              </a:spcAft>
+              <a:defRPr sz="900">
+                <a:solidFill>
+                  <a:srgbClr val="5C6B8A"/>
+                </a:solidFill>
+                <a:latin typeface="Calibri"/>
+              </a:defRPr>
+            </a:pPr>
+            <a:r>
+              <a:t>•  Google ADK agent flows</a:t>
+            </a:r>
+          </a:p>
+          <a:p>
+            <a:pPr>
+              <a:spcAft>
+                <a:spcPts val="300"/>
+              </a:spcAft>
+              <a:defRPr sz="900">
+                <a:solidFill>
+                  <a:srgbClr val="5C6B8A"/>
+                </a:solidFill>
+                <a:latin typeface="Calibri"/>
+              </a:defRPr>
+            </a:pPr>
+            <a:r>
+              <a:t>•  Sandbox runtime integration</a:t>
+            </a:r>
+          </a:p>
+        </p:txBody>
+      </p:sp>
+      <p:sp>
+        <p:nvSpPr>
+          <p:cNvPr id="10" name="Rectangle 9"/>
+          <p:cNvSpPr/>
+          <p:nvPr/>
+        </p:nvSpPr>
+        <p:spPr>
+          <a:xfrm>
+            <a:off x="3363468" y="1828800"/>
+            <a:ext cx="2650236" cy="4150000"/>
+          </a:xfrm>
+          <a:prstGeom prst="rect">
+            <a:avLst/>
+          </a:prstGeom>
+          <a:solidFill>
+            <a:srgbClr val="EDF2FB"/>
+          </a:solidFill>
+          <a:ln>
+            <a:noFill/>
+          </a:ln>
+        </p:spPr>
+        <p:style>
+          <a:lnRef idx="1">
+            <a:schemeClr val="accent1"/>
+          </a:lnRef>
+          <a:fillRef idx="3">
+            <a:schemeClr val="accent1"/>
+          </a:fillRef>
+          <a:effectRef idx="2">
+            <a:schemeClr val="accent1"/>
+          </a:effectRef>
+          <a:fontRef idx="minor">
+            <a:schemeClr val="lt1"/>
+          </a:fontRef>
+        </p:style>
+        <p:txBody>
+          <a:bodyPr rtlCol="0" anchor="ctr"/>
+          <a:lstStyle/>
+          <a:p>
+            <a:pPr algn="ctr"/>
+          </a:p>
+        </p:txBody>
+      </p:sp>
+      <p:sp>
+        <p:nvSpPr>
+          <p:cNvPr id="11" name="Oval 10"/>
+          <p:cNvSpPr/>
+          <p:nvPr/>
+        </p:nvSpPr>
+        <p:spPr>
+          <a:xfrm>
+            <a:off x="3528060" y="1993392"/>
+            <a:ext cx="502920" cy="502920"/>
+          </a:xfrm>
+          <a:prstGeom prst="ellipse">
+            <a:avLst/>
+          </a:prstGeom>
+          <a:solidFill>
+            <a:srgbClr val="DCE5F7"/>
+          </a:solidFill>
+          <a:ln>
+            <a:noFill/>
+          </a:ln>
+        </p:spPr>
+        <p:style>
+          <a:lnRef idx="1">
+            <a:schemeClr val="accent1"/>
+          </a:lnRef>
+          <a:fillRef idx="3">
+            <a:schemeClr val="accent1"/>
+          </a:fillRef>
+          <a:effectRef idx="2">
+            <a:schemeClr val="accent1"/>
+          </a:effectRef>
+          <a:fontRef idx="minor">
+            <a:schemeClr val="lt1"/>
+          </a:fontRef>
+        </p:style>
+        <p:txBody>
+          <a:bodyPr rtlCol="0" anchor="ctr"/>
+          <a:lstStyle/>
+          <a:p>
+            <a:pPr algn="ctr"/>
+          </a:p>
+        </p:txBody>
+      </p:sp>
+      <p:pic>
+        <p:nvPicPr>
+          <p:cNvPr id="12" name="Picture 11" descr="image.png"/>
+          <p:cNvPicPr>
+            <a:picLocks noChangeAspect="1"/>
+          </p:cNvPicPr>
+          <p:nvPr/>
+        </p:nvPicPr>
+        <p:blipFill>
+          <a:blip r:embed="rId3"/>
+          <a:stretch>
+            <a:fillRect/>
+          </a:stretch>
+        </p:blipFill>
+        <p:spPr>
+          <a:xfrm>
+            <a:off x="3658819" y="2124151"/>
+            <a:ext cx="241402" cy="241402"/>
+          </a:xfrm>
+          <a:prstGeom prst="rect">
+            <a:avLst/>
+          </a:prstGeom>
+        </p:spPr>
+      </p:pic>
+      <p:sp>
+        <p:nvSpPr>
+          <p:cNvPr id="13" name="TextBox 12"/>
+          <p:cNvSpPr txBox="1"/>
+          <p:nvPr/>
+        </p:nvSpPr>
+        <p:spPr>
+          <a:xfrm>
+            <a:off x="4113468" y="1948800"/>
+            <a:ext cx="1750000" cy="600000"/>
+          </a:xfrm>
+          <a:prstGeom prst="rect">
+            <a:avLst/>
+          </a:prstGeom>
+          <a:noFill/>
+        </p:spPr>
+        <p:txBody>
+          <a:bodyPr wrap="square" lIns="0" rIns="0" tIns="0" bIns="0">
+            <a:spAutoFit/>
+          </a:bodyPr>
+          <a:lstStyle/>
+          <a:p>
+            <a:pPr>
+              <a:spcAft>
+                <a:spcPts val="100"/>
+              </a:spcAft>
+              <a:defRPr sz="1300" b="1">
+                <a:solidFill>
+                  <a:srgbClr val="14213D"/>
+                </a:solidFill>
+                <a:latin typeface="Calibri"/>
+              </a:defRPr>
+            </a:pPr>
+            <a:r>
+              <a:t>Yuvaraj</a:t>
+            </a:r>
+          </a:p>
+          <a:p>
+            <a:pPr>
+              <a:defRPr sz="950" b="1">
+                <a:solidFill>
+                  <a:srgbClr val="E05C2A"/>
+                </a:solidFill>
+                <a:latin typeface="Calibri"/>
+              </a:defRPr>
+            </a:pPr>
+            <a:r>
+              <a:t>Frontend UI/UX Engineer</a:t>
+            </a:r>
+          </a:p>
+        </p:txBody>
+      </p:sp>
+      <p:sp>
+        <p:nvSpPr>
+          <p:cNvPr id="14" name="TextBox 13"/>
+          <p:cNvSpPr txBox="1"/>
+          <p:nvPr/>
+        </p:nvSpPr>
+        <p:spPr>
+          <a:xfrm>
+            <a:off x="3528060" y="2628800"/>
+            <a:ext cx="2321052" cy="3250000"/>
+          </a:xfrm>
+          <a:prstGeom prst="rect">
+            <a:avLst/>
+          </a:prstGeom>
+          <a:noFill/>
+        </p:spPr>
+        <p:txBody>
+          <a:bodyPr wrap="square" lIns="0" rIns="0" tIns="0" bIns="0">
+            <a:spAutoFit/>
+          </a:bodyPr>
+          <a:lstStyle/>
+          <a:p>
+            <a:pPr>
+              <a:spcAft>
+                <a:spcPts val="200"/>
+              </a:spcAft>
+              <a:defRPr sz="950" b="1">
+                <a:solidFill>
+                  <a:srgbClr val="14213D"/>
+                </a:solidFill>
+                <a:latin typeface="Calibri"/>
+              </a:defRPr>
+            </a:pPr>
+            <a:r>
+              <a:t>FOCUS</a:t>
+            </a:r>
+          </a:p>
+          <a:p>
+            <a:pPr>
+              <a:spcAft>
+                <a:spcPts val="800"/>
+              </a:spcAft>
+              <a:defRPr sz="950">
+                <a:solidFill>
+                  <a:srgbClr val="5C6B8A"/>
+                </a:solidFill>
+                <a:latin typeface="Calibri"/>
+              </a:defRPr>
+            </a:pPr>
+            <a:r>
+              <a:t>UI Components, Client State, Interaction</a:t>
+            </a:r>
+          </a:p>
+          <a:p>
+            <a:pPr>
+              <a:spcAft>
+                <a:spcPts val="400"/>
+              </a:spcAft>
+              <a:defRPr sz="950" b="1">
+                <a:solidFill>
+                  <a:srgbClr val="14213D"/>
+                </a:solidFill>
+                <a:latin typeface="Calibri"/>
+              </a:defRPr>
+            </a:pPr>
+            <a:r>
+              <a:t>RESPONSIBILITIES</a:t>
+            </a:r>
+          </a:p>
+          <a:p>
+            <a:pPr>
+              <a:spcAft>
+                <a:spcPts val="300"/>
+              </a:spcAft>
+              <a:defRPr sz="900">
+                <a:solidFill>
+                  <a:srgbClr val="5C6B8A"/>
+                </a:solidFill>
+                <a:latin typeface="Calibri"/>
+              </a:defRPr>
+            </a:pPr>
+            <a:r>
+              <a:t>•  Responsive portal dashboards</a:t>
+            </a:r>
+          </a:p>
+          <a:p>
+            <a:pPr>
+              <a:spcAft>
+                <a:spcPts val="300"/>
+              </a:spcAft>
+              <a:defRPr sz="900">
+                <a:solidFill>
+                  <a:srgbClr val="5C6B8A"/>
+                </a:solidFill>
+                <a:latin typeface="Calibri"/>
+              </a:defRPr>
+            </a:pPr>
+            <a:r>
+              <a:t>•  Gantt/Kanban dynamic views</a:t>
+            </a:r>
+          </a:p>
+          <a:p>
+            <a:pPr>
+              <a:spcAft>
+                <a:spcPts val="300"/>
+              </a:spcAft>
+              <a:defRPr sz="900">
+                <a:solidFill>
+                  <a:srgbClr val="5C6B8A"/>
+                </a:solidFill>
+                <a:latin typeface="Calibri"/>
+              </a:defRPr>
+            </a:pPr>
+            <a:r>
+              <a:t>•  Streaming AI chat UI</a:t>
+            </a:r>
+          </a:p>
+          <a:p>
+            <a:pPr>
+              <a:spcAft>
+                <a:spcPts val="300"/>
+              </a:spcAft>
+              <a:defRPr sz="900">
+                <a:solidFill>
+                  <a:srgbClr val="5C6B8A"/>
+                </a:solidFill>
+                <a:latin typeface="Calibri"/>
+              </a:defRPr>
+            </a:pPr>
+            <a:r>
+              <a:t>•  Playwright E2E visual tests</a:t>
+            </a:r>
+          </a:p>
+        </p:txBody>
+      </p:sp>
+      <p:sp>
+        <p:nvSpPr>
+          <p:cNvPr id="15" name="Rectangle 14"/>
+          <p:cNvSpPr/>
+          <p:nvPr/>
+        </p:nvSpPr>
+        <p:spPr>
+          <a:xfrm>
+            <a:off x="6178296" y="1828800"/>
+            <a:ext cx="2650236" cy="4150000"/>
+          </a:xfrm>
+          <a:prstGeom prst="rect">
+            <a:avLst/>
+          </a:prstGeom>
+          <a:solidFill>
+            <a:srgbClr val="EDF2FB"/>
+          </a:solidFill>
+          <a:ln>
+            <a:noFill/>
+          </a:ln>
+        </p:spPr>
+        <p:style>
+          <a:lnRef idx="1">
+            <a:schemeClr val="accent1"/>
+          </a:lnRef>
+          <a:fillRef idx="3">
+            <a:schemeClr val="accent1"/>
+          </a:fillRef>
+          <a:effectRef idx="2">
+            <a:schemeClr val="accent1"/>
+          </a:effectRef>
+          <a:fontRef idx="minor">
+            <a:schemeClr val="lt1"/>
+          </a:fontRef>
+        </p:style>
+        <p:txBody>
+          <a:bodyPr rtlCol="0" anchor="ctr"/>
+          <a:lstStyle/>
+          <a:p>
+            <a:pPr algn="ctr"/>
+          </a:p>
+        </p:txBody>
+      </p:sp>
+      <p:sp>
+        <p:nvSpPr>
+          <p:cNvPr id="16" name="Oval 15"/>
+          <p:cNvSpPr/>
+          <p:nvPr/>
+        </p:nvSpPr>
+        <p:spPr>
+          <a:xfrm>
+            <a:off x="6342888" y="1993392"/>
+            <a:ext cx="502920" cy="502920"/>
+          </a:xfrm>
+          <a:prstGeom prst="ellipse">
+            <a:avLst/>
+          </a:prstGeom>
+          <a:solidFill>
+            <a:srgbClr val="DCE5F7"/>
+          </a:solidFill>
+          <a:ln>
+            <a:noFill/>
+          </a:ln>
+        </p:spPr>
+        <p:style>
+          <a:lnRef idx="1">
+            <a:schemeClr val="accent1"/>
+          </a:lnRef>
+          <a:fillRef idx="3">
+            <a:schemeClr val="accent1"/>
+          </a:fillRef>
+          <a:effectRef idx="2">
+            <a:schemeClr val="accent1"/>
+          </a:effectRef>
+          <a:fontRef idx="minor">
+            <a:schemeClr val="lt1"/>
+          </a:fontRef>
+        </p:style>
+        <p:txBody>
+          <a:bodyPr rtlCol="0" anchor="ctr"/>
+          <a:lstStyle/>
+          <a:p>
+            <a:pPr algn="ctr"/>
+          </a:p>
+        </p:txBody>
+      </p:sp>
+      <p:pic>
+        <p:nvPicPr>
+          <p:cNvPr id="17" name="Picture 16" descr="image.png"/>
+          <p:cNvPicPr>
+            <a:picLocks noChangeAspect="1"/>
+          </p:cNvPicPr>
+          <p:nvPr/>
+        </p:nvPicPr>
+        <p:blipFill>
+          <a:blip r:embed="rId4"/>
+          <a:stretch>
+            <a:fillRect/>
+          </a:stretch>
+        </p:blipFill>
+        <p:spPr>
+          <a:xfrm>
+            <a:off x="6473647" y="2124151"/>
+            <a:ext cx="241402" cy="241402"/>
+          </a:xfrm>
+          <a:prstGeom prst="rect">
+            <a:avLst/>
+          </a:prstGeom>
+        </p:spPr>
+      </p:pic>
+      <p:sp>
+        <p:nvSpPr>
+          <p:cNvPr id="18" name="TextBox 17"/>
+          <p:cNvSpPr txBox="1"/>
+          <p:nvPr/>
+        </p:nvSpPr>
+        <p:spPr>
+          <a:xfrm>
+            <a:off x="6928296" y="1948800"/>
+            <a:ext cx="1750000" cy="600000"/>
+          </a:xfrm>
+          <a:prstGeom prst="rect">
+            <a:avLst/>
+          </a:prstGeom>
+          <a:noFill/>
+        </p:spPr>
+        <p:txBody>
+          <a:bodyPr wrap="square" lIns="0" rIns="0" tIns="0" bIns="0">
+            <a:spAutoFit/>
+          </a:bodyPr>
+          <a:lstStyle/>
+          <a:p>
+            <a:pPr>
+              <a:spcAft>
+                <a:spcPts val="100"/>
+              </a:spcAft>
+              <a:defRPr sz="1300" b="1">
+                <a:solidFill>
+                  <a:srgbClr val="14213D"/>
+                </a:solidFill>
+                <a:latin typeface="Calibri"/>
+              </a:defRPr>
+            </a:pPr>
+            <a:r>
+              <a:t>Vijesh</a:t>
+            </a:r>
+          </a:p>
+          <a:p>
+            <a:pPr>
+              <a:defRPr sz="950" b="1">
+                <a:solidFill>
+                  <a:srgbClr val="E05C2A"/>
+                </a:solidFill>
+                <a:latin typeface="Calibri"/>
+              </a:defRPr>
+            </a:pPr>
+            <a:r>
+              <a:t>Backend &amp; Database Engineer</a:t>
+            </a:r>
+          </a:p>
+        </p:txBody>
+      </p:sp>
+      <p:sp>
+        <p:nvSpPr>
+          <p:cNvPr id="19" name="TextBox 18"/>
+          <p:cNvSpPr txBox="1"/>
+          <p:nvPr/>
+        </p:nvSpPr>
+        <p:spPr>
+          <a:xfrm>
+            <a:off x="6342888" y="2628800"/>
+            <a:ext cx="2321052" cy="3250000"/>
+          </a:xfrm>
+          <a:prstGeom prst="rect">
+            <a:avLst/>
+          </a:prstGeom>
+          <a:noFill/>
+        </p:spPr>
+        <p:txBody>
+          <a:bodyPr wrap="square" lIns="0" rIns="0" tIns="0" bIns="0">
+            <a:spAutoFit/>
+          </a:bodyPr>
+          <a:lstStyle/>
+          <a:p>
+            <a:pPr>
+              <a:spcAft>
+                <a:spcPts val="200"/>
+              </a:spcAft>
+              <a:defRPr sz="950" b="1">
+                <a:solidFill>
+                  <a:srgbClr val="14213D"/>
+                </a:solidFill>
+                <a:latin typeface="Calibri"/>
+              </a:defRPr>
+            </a:pPr>
+            <a:r>
+              <a:t>FOCUS</a:t>
+            </a:r>
+          </a:p>
+          <a:p>
+            <a:pPr>
+              <a:spcAft>
+                <a:spcPts val="800"/>
+              </a:spcAft>
+              <a:defRPr sz="950">
+                <a:solidFill>
+                  <a:srgbClr val="5C6B8A"/>
+                </a:solidFill>
+                <a:latin typeface="Calibri"/>
+              </a:defRPr>
+            </a:pPr>
+            <a:r>
+              <a:t>DB Schema, Ingestion Pipelines, Caching</a:t>
+            </a:r>
+          </a:p>
+          <a:p>
+            <a:pPr>
+              <a:spcAft>
+                <a:spcPts val="400"/>
+              </a:spcAft>
+              <a:defRPr sz="950" b="1">
+                <a:solidFill>
+                  <a:srgbClr val="14213D"/>
+                </a:solidFill>
+                <a:latin typeface="Calibri"/>
+              </a:defRPr>
+            </a:pPr>
+            <a:r>
+              <a:t>RESPONSIBILITIES</a:t>
+            </a:r>
+          </a:p>
+          <a:p>
+            <a:pPr>
+              <a:spcAft>
+                <a:spcPts val="300"/>
+              </a:spcAft>
+              <a:defRPr sz="900">
+                <a:solidFill>
+                  <a:srgbClr val="5C6B8A"/>
+                </a:solidFill>
+                <a:latin typeface="Calibri"/>
+              </a:defRPr>
+            </a:pPr>
+            <a:r>
+              <a:t>•  Postgres migrations &amp; pgvector</a:t>
+            </a:r>
+          </a:p>
+          <a:p>
+            <a:pPr>
+              <a:spcAft>
+                <a:spcPts val="300"/>
+              </a:spcAft>
+              <a:defRPr sz="900">
+                <a:solidFill>
+                  <a:srgbClr val="5C6B8A"/>
+                </a:solidFill>
+                <a:latin typeface="Calibri"/>
+              </a:defRPr>
+            </a:pPr>
+            <a:r>
+              <a:t>•  CSV/Excel parsing engine</a:t>
+            </a:r>
+          </a:p>
+          <a:p>
+            <a:pPr>
+              <a:spcAft>
+                <a:spcPts val="300"/>
+              </a:spcAft>
+              <a:defRPr sz="900">
+                <a:solidFill>
+                  <a:srgbClr val="5C6B8A"/>
+                </a:solidFill>
+                <a:latin typeface="Calibri"/>
+              </a:defRPr>
+            </a:pPr>
+            <a:r>
+              <a:t>•  Redis session/rate limiting</a:t>
+            </a:r>
+          </a:p>
+          <a:p>
+            <a:pPr>
+              <a:spcAft>
+                <a:spcPts val="300"/>
+              </a:spcAft>
+              <a:defRPr sz="900">
+                <a:solidFill>
+                  <a:srgbClr val="5C6B8A"/>
+                </a:solidFill>
+                <a:latin typeface="Calibri"/>
+              </a:defRPr>
+            </a:pPr>
+            <a:r>
+              <a:t>•  Row-Level Security policies</a:t>
+            </a:r>
+          </a:p>
+        </p:txBody>
+      </p:sp>
+      <p:sp>
+        <p:nvSpPr>
+          <p:cNvPr id="20" name="Rectangle 19"/>
+          <p:cNvSpPr/>
+          <p:nvPr/>
+        </p:nvSpPr>
+        <p:spPr>
+          <a:xfrm>
+            <a:off x="8993124" y="1828800"/>
+            <a:ext cx="2650236" cy="4150000"/>
+          </a:xfrm>
+          <a:prstGeom prst="rect">
+            <a:avLst/>
+          </a:prstGeom>
+          <a:solidFill>
+            <a:srgbClr val="EDF2FB"/>
+          </a:solidFill>
+          <a:ln>
+            <a:noFill/>
+          </a:ln>
+        </p:spPr>
+        <p:style>
+          <a:lnRef idx="1">
+            <a:schemeClr val="accent1"/>
+          </a:lnRef>
+          <a:fillRef idx="3">
+            <a:schemeClr val="accent1"/>
+          </a:fillRef>
+          <a:effectRef idx="2">
+            <a:schemeClr val="accent1"/>
+          </a:effectRef>
+          <a:fontRef idx="minor">
+            <a:schemeClr val="lt1"/>
+          </a:fontRef>
+        </p:style>
+        <p:txBody>
+          <a:bodyPr rtlCol="0" anchor="ctr"/>
+          <a:lstStyle/>
+          <a:p>
+            <a:pPr algn="ctr"/>
+          </a:p>
+        </p:txBody>
+      </p:sp>
+      <p:sp>
+        <p:nvSpPr>
+          <p:cNvPr id="21" name="Oval 20"/>
+          <p:cNvSpPr/>
+          <p:nvPr/>
+        </p:nvSpPr>
+        <p:spPr>
+          <a:xfrm>
+            <a:off x="9157716" y="1993392"/>
+            <a:ext cx="502920" cy="502920"/>
+          </a:xfrm>
+          <a:prstGeom prst="ellipse">
+            <a:avLst/>
+          </a:prstGeom>
+          <a:solidFill>
+            <a:srgbClr val="DCE5F7"/>
+          </a:solidFill>
+          <a:ln>
+            <a:noFill/>
+          </a:ln>
+        </p:spPr>
+        <p:style>
+          <a:lnRef idx="1">
+            <a:schemeClr val="accent1"/>
+          </a:lnRef>
+          <a:fillRef idx="3">
+            <a:schemeClr val="accent1"/>
+          </a:fillRef>
+          <a:effectRef idx="2">
+            <a:schemeClr val="accent1"/>
+          </a:effectRef>
+          <a:fontRef idx="minor">
+            <a:schemeClr val="lt1"/>
+          </a:fontRef>
+        </p:style>
+        <p:txBody>
+          <a:bodyPr rtlCol="0" anchor="ctr"/>
+          <a:lstStyle/>
+          <a:p>
+            <a:pPr algn="ctr"/>
+          </a:p>
+        </p:txBody>
+      </p:sp>
+      <p:pic>
+        <p:nvPicPr>
+          <p:cNvPr id="22" name="Picture 21" descr="image.png"/>
+          <p:cNvPicPr>
+            <a:picLocks noChangeAspect="1"/>
+          </p:cNvPicPr>
+          <p:nvPr/>
+        </p:nvPicPr>
+        <p:blipFill>
+          <a:blip r:embed="rId5"/>
+          <a:stretch>
+            <a:fillRect/>
+          </a:stretch>
+        </p:blipFill>
+        <p:spPr>
+          <a:xfrm>
+            <a:off x="9288475" y="2124151"/>
+            <a:ext cx="241402" cy="241402"/>
+          </a:xfrm>
+          <a:prstGeom prst="rect">
+            <a:avLst/>
+          </a:prstGeom>
+        </p:spPr>
+      </p:pic>
+      <p:sp>
+        <p:nvSpPr>
+          <p:cNvPr id="23" name="TextBox 22"/>
+          <p:cNvSpPr txBox="1"/>
+          <p:nvPr/>
+        </p:nvSpPr>
+        <p:spPr>
+          <a:xfrm>
+            <a:off x="9743124" y="1948800"/>
+            <a:ext cx="1750000" cy="600000"/>
+          </a:xfrm>
+          <a:prstGeom prst="rect">
+            <a:avLst/>
+          </a:prstGeom>
+          <a:noFill/>
+        </p:spPr>
+        <p:txBody>
+          <a:bodyPr wrap="square" lIns="0" rIns="0" tIns="0" bIns="0">
+            <a:spAutoFit/>
+          </a:bodyPr>
+          <a:lstStyle/>
+          <a:p>
+            <a:pPr>
+              <a:spcAft>
+                <a:spcPts val="100"/>
+              </a:spcAft>
+              <a:defRPr sz="1300" b="1">
+                <a:solidFill>
+                  <a:srgbClr val="14213D"/>
+                </a:solidFill>
+                <a:latin typeface="Calibri"/>
+              </a:defRPr>
+            </a:pPr>
+            <a:r>
+              <a:t>Santosh</a:t>
+            </a:r>
+          </a:p>
+          <a:p>
+            <a:pPr>
+              <a:defRPr sz="950" b="1">
+                <a:solidFill>
+                  <a:srgbClr val="E05C2A"/>
+                </a:solidFill>
+                <a:latin typeface="Calibri"/>
+              </a:defRPr>
+            </a:pPr>
+            <a:r>
+              <a:t>DevSecOps &amp; QA Lead</a:t>
+            </a:r>
+          </a:p>
+        </p:txBody>
+      </p:sp>
+      <p:sp>
+        <p:nvSpPr>
+          <p:cNvPr id="24" name="TextBox 23"/>
+          <p:cNvSpPr txBox="1"/>
+          <p:nvPr/>
+        </p:nvSpPr>
+        <p:spPr>
+          <a:xfrm>
+            <a:off x="9157716" y="2628800"/>
+            <a:ext cx="2321052" cy="3250000"/>
+          </a:xfrm>
+          <a:prstGeom prst="rect">
+            <a:avLst/>
+          </a:prstGeom>
+          <a:noFill/>
+        </p:spPr>
+        <p:txBody>
+          <a:bodyPr wrap="square" lIns="0" rIns="0" tIns="0" bIns="0">
+            <a:spAutoFit/>
+          </a:bodyPr>
+          <a:lstStyle/>
+          <a:p>
+            <a:pPr>
+              <a:spcAft>
+                <a:spcPts val="200"/>
+              </a:spcAft>
+              <a:defRPr sz="950" b="1">
+                <a:solidFill>
+                  <a:srgbClr val="14213D"/>
+                </a:solidFill>
+                <a:latin typeface="Calibri"/>
+              </a:defRPr>
+            </a:pPr>
+            <a:r>
+              <a:t>FOCUS</a:t>
+            </a:r>
+          </a:p>
+          <a:p>
+            <a:pPr>
+              <a:spcAft>
+                <a:spcPts val="800"/>
+              </a:spcAft>
+              <a:defRPr sz="950">
+                <a:solidFill>
+                  <a:srgbClr val="5C6B8A"/>
+                </a:solidFill>
+                <a:latin typeface="Calibri"/>
+              </a:defRPr>
+            </a:pPr>
+            <a:r>
+              <a:t>DevOps, Security Audits, QA Automation</a:t>
+            </a:r>
+          </a:p>
+          <a:p>
+            <a:pPr>
+              <a:spcAft>
+                <a:spcPts val="400"/>
+              </a:spcAft>
+              <a:defRPr sz="950" b="1">
+                <a:solidFill>
+                  <a:srgbClr val="14213D"/>
+                </a:solidFill>
+                <a:latin typeface="Calibri"/>
+              </a:defRPr>
+            </a:pPr>
+            <a:r>
+              <a:t>RESPONSIBILITIES</a:t>
+            </a:r>
+          </a:p>
+          <a:p>
+            <a:pPr>
+              <a:spcAft>
+                <a:spcPts val="300"/>
+              </a:spcAft>
+              <a:defRPr sz="900">
+                <a:solidFill>
+                  <a:srgbClr val="5C6B8A"/>
+                </a:solidFill>
+                <a:latin typeface="Calibri"/>
+              </a:defRPr>
+            </a:pPr>
+            <a:r>
+              <a:t>•  AWS/Vercel/Docker CI/CD</a:t>
+            </a:r>
+          </a:p>
+          <a:p>
+            <a:pPr>
+              <a:spcAft>
+                <a:spcPts val="300"/>
+              </a:spcAft>
+              <a:defRPr sz="900">
+                <a:solidFill>
+                  <a:srgbClr val="5C6B8A"/>
+                </a:solidFill>
+                <a:latin typeface="Calibri"/>
+              </a:defRPr>
+            </a:pPr>
+            <a:r>
+              <a:t>•  Isolated code execution sandbox</a:t>
+            </a:r>
+          </a:p>
+          <a:p>
+            <a:pPr>
+              <a:spcAft>
+                <a:spcPts val="300"/>
+              </a:spcAft>
+              <a:defRPr sz="900">
+                <a:solidFill>
+                  <a:srgbClr val="5C6B8A"/>
+                </a:solidFill>
+                <a:latin typeface="Calibri"/>
+              </a:defRPr>
+            </a:pPr>
+            <a:r>
+              <a:t>•  Vitest/Playwright test suites</a:t>
+            </a:r>
+          </a:p>
+          <a:p>
+            <a:pPr>
+              <a:spcAft>
+                <a:spcPts val="300"/>
+              </a:spcAft>
+              <a:defRPr sz="900">
+                <a:solidFill>
+                  <a:srgbClr val="5C6B8A"/>
+                </a:solidFill>
+                <a:latin typeface="Calibri"/>
+              </a:defRPr>
+            </a:pPr>
+            <a:r>
+              <a:t>•  Sentry &amp; OpenTelemetry logs</a:t>
+            </a:r>
+          </a:p>
+        </p:txBody>
+      </p:sp>
+      <p:pic>
+        <p:nvPicPr>
+          <p:cNvPr id="25" name="Picture 24" descr="image.png">
+            <a:hlinkClick action="ppaction://hlinksldjump" r:id="rId7"/>
+          </p:cNvPr>
+          <p:cNvPicPr>
+            <a:picLocks noChangeAspect="1"/>
+          </p:cNvPicPr>
+          <p:nvPr/>
+        </p:nvPicPr>
+        <p:blipFill>
+          <a:blip r:embed="rId6"/>
+          <a:stretch>
+            <a:fillRect/>
+          </a:stretch>
+        </p:blipFill>
+        <p:spPr>
+          <a:xfrm>
+            <a:off x="548640" y="6382512"/>
+            <a:ext cx="201168" cy="201168"/>
+          </a:xfrm>
+          <a:prstGeom prst="rect">
+            <a:avLst/>
+          </a:prstGeom>
+        </p:spPr>
+      </p:pic>
+      <p:sp>
+        <p:nvSpPr>
+          <p:cNvPr id="26" name="TextBox 25">
+            <a:hlinkClick action="ppaction://hlinksldjump" r:id="rId7"/>
+          </p:cNvPr>
+          <p:cNvSpPr txBox="1"/>
+          <p:nvPr/>
+        </p:nvSpPr>
+        <p:spPr>
+          <a:xfrm>
+            <a:off x="841248" y="6355080"/>
+            <a:ext cx="2377440" cy="365760"/>
+          </a:xfrm>
+          <a:prstGeom prst="rect">
+            <a:avLst/>
+          </a:prstGeom>
+          <a:noFill/>
+        </p:spPr>
+        <p:txBody>
+          <a:bodyPr wrap="square" lIns="0" rIns="0" tIns="0" bIns="0">
+            <a:spAutoFit/>
+          </a:bodyPr>
+          <a:lstStyle/>
+          <a:p>
+            <a:pPr>
+              <a:defRPr sz="1100">
+                <a:solidFill>
+                  <a:srgbClr val="14213D"/>
+                </a:solidFill>
+                <a:latin typeface="Calibri"/>
+              </a:defRPr>
+            </a:pPr>
+            <a:r>
+              <a:t>BACK TO REVIEW BOARD</a:t>
+            </a:r>
+          </a:p>
+        </p:txBody>
+      </p:sp>
+      <p:sp>
+        <p:nvSpPr>
+          <p:cNvPr id="27" name="TextBox 26">
+            <a:hlinkClick action="ppaction://hlinksldjump" r:id="rId8"/>
+          </p:cNvPr>
+          <p:cNvSpPr txBox="1"/>
+          <p:nvPr/>
+        </p:nvSpPr>
+        <p:spPr>
+          <a:xfrm>
+            <a:off x="7680960" y="6327648"/>
+            <a:ext cx="3840480" cy="365760"/>
+          </a:xfrm>
+          <a:prstGeom prst="rect">
+            <a:avLst/>
+          </a:prstGeom>
+          <a:noFill/>
+        </p:spPr>
+        <p:txBody>
+          <a:bodyPr wrap="square" lIns="0" rIns="0" tIns="0" bIns="0">
+            <a:spAutoFit/>
+          </a:bodyPr>
+          <a:lstStyle/>
+          <a:p>
+            <a:pPr algn="r">
+              <a:defRPr sz="1100">
+                <a:solidFill>
+                  <a:srgbClr val="E05C2A"/>
+                </a:solidFill>
+                <a:latin typeface="Calibri"/>
+              </a:defRPr>
+            </a:pPr>
+            <a:r>
+              <a:t>CONTINUE TO SANCTION DECISION  →</a:t>
+            </a:r>
+          </a:p>
+        </p:txBody>
+      </p:sp>
+      <p:sp>
+        <p:nvSpPr>
+          <p:cNvPr id="28" name="TextBox 27"/>
+          <p:cNvSpPr txBox="1"/>
+          <p:nvPr/>
+        </p:nvSpPr>
+        <p:spPr>
+          <a:xfrm>
+            <a:off x="8595360" y="6382512"/>
+            <a:ext cx="3017520" cy="274320"/>
+          </a:xfrm>
+          <a:prstGeom prst="rect">
+            <a:avLst/>
+          </a:prstGeom>
+          <a:noFill/>
+        </p:spPr>
+        <p:txBody>
+          <a:bodyPr wrap="square" lIns="0" rIns="0" tIns="0" bIns="0">
+            <a:spAutoFit/>
+          </a:bodyPr>
+          <a:lstStyle/>
+          <a:p>
+            <a:pPr algn="r">
+              <a:defRPr sz="1000">
+                <a:solidFill>
+                  <a:srgbClr val="A6B0C8"/>
+                </a:solidFill>
+                <a:latin typeface="Calibri"/>
+              </a:defRPr>
+            </a:pPr>
+            <a:r>
+              <a:t>Cadence Review · Team Roles</a:t>
+            </a:r>
           </a:p>
         </p:txBody>
       </p:sp>

</xml_diff>